<commit_message>
Added updated version of presentation slides
</commit_message>
<xml_diff>
--- a/OOO_TomasulosAlg_pdf.pptx
+++ b/OOO_TomasulosAlg_pdf.pptx
@@ -131,7 +131,7 @@
   <pc:docChgLst>
     <pc:chgData name="Antonio Anzora Jr" userId="0b7f19ef104c8f31" providerId="LiveId" clId="{728442DB-1AEA-44B8-B1D6-594786BBEB5D}"/>
     <pc:docChg chg="undo custSel addSld delSld modSld sldOrd">
-      <pc:chgData name="Antonio Anzora Jr" userId="0b7f19ef104c8f31" providerId="LiveId" clId="{728442DB-1AEA-44B8-B1D6-594786BBEB5D}" dt="2026-05-04T02:04:44.078" v="5438" actId="20577"/>
+      <pc:chgData name="Antonio Anzora Jr" userId="0b7f19ef104c8f31" providerId="LiveId" clId="{728442DB-1AEA-44B8-B1D6-594786BBEB5D}" dt="2026-05-06T08:27:18.327" v="5441" actId="22"/>
       <pc:docMkLst>
         <pc:docMk/>
       </pc:docMkLst>
@@ -142,8 +142,8 @@
           <pc:sldMk cId="2475805559" sldId="257"/>
         </pc:sldMkLst>
       </pc:sldChg>
-      <pc:sldChg chg="modSp mod">
-        <pc:chgData name="Antonio Anzora Jr" userId="0b7f19ef104c8f31" providerId="LiveId" clId="{728442DB-1AEA-44B8-B1D6-594786BBEB5D}" dt="2026-05-03T21:11:06.905" v="5394" actId="20577"/>
+      <pc:sldChg chg="addSp delSp modSp mod">
+        <pc:chgData name="Antonio Anzora Jr" userId="0b7f19ef104c8f31" providerId="LiveId" clId="{728442DB-1AEA-44B8-B1D6-594786BBEB5D}" dt="2026-05-06T08:27:18.327" v="5441" actId="22"/>
         <pc:sldMkLst>
           <pc:docMk/>
           <pc:sldMk cId="4289888808" sldId="260"/>
@@ -156,9 +156,17 @@
             <ac:spMk id="3" creationId="{ACCD2DCA-6B1C-0E06-F33B-20978CDDE251}"/>
           </ac:spMkLst>
         </pc:spChg>
+        <pc:spChg chg="add del">
+          <ac:chgData name="Antonio Anzora Jr" userId="0b7f19ef104c8f31" providerId="LiveId" clId="{728442DB-1AEA-44B8-B1D6-594786BBEB5D}" dt="2026-05-06T08:27:18.327" v="5441" actId="22"/>
+          <ac:spMkLst>
+            <pc:docMk/>
+            <pc:sldMk cId="4289888808" sldId="260"/>
+            <ac:spMk id="6" creationId="{EB2C06F0-55F7-0611-6167-EC00EA659404}"/>
+          </ac:spMkLst>
+        </pc:spChg>
       </pc:sldChg>
       <pc:sldChg chg="modSp mod modNotesTx">
-        <pc:chgData name="Antonio Anzora Jr" userId="0b7f19ef104c8f31" providerId="LiveId" clId="{728442DB-1AEA-44B8-B1D6-594786BBEB5D}" dt="2026-05-03T21:12:26.379" v="5416" actId="20577"/>
+        <pc:chgData name="Antonio Anzora Jr" userId="0b7f19ef104c8f31" providerId="LiveId" clId="{728442DB-1AEA-44B8-B1D6-594786BBEB5D}" dt="2026-05-06T07:16:18.191" v="5439" actId="20577"/>
         <pc:sldMkLst>
           <pc:docMk/>
           <pc:sldMk cId="2832139573" sldId="261"/>
@@ -171,13 +179,6 @@
             <ac:spMk id="3" creationId="{72B7D73D-08B9-93EE-6CAB-3D4D574786D6}"/>
           </ac:spMkLst>
         </pc:spChg>
-      </pc:sldChg>
-      <pc:sldChg chg="del">
-        <pc:chgData name="Antonio Anzora Jr" userId="0b7f19ef104c8f31" providerId="LiveId" clId="{728442DB-1AEA-44B8-B1D6-594786BBEB5D}" dt="2026-05-03T20:07:15.473" v="753" actId="2696"/>
-        <pc:sldMkLst>
-          <pc:docMk/>
-          <pc:sldMk cId="2122663000" sldId="262"/>
-        </pc:sldMkLst>
       </pc:sldChg>
       <pc:sldChg chg="modSp mod modNotesTx">
         <pc:chgData name="Antonio Anzora Jr" userId="0b7f19ef104c8f31" providerId="LiveId" clId="{728442DB-1AEA-44B8-B1D6-594786BBEB5D}" dt="2026-05-03T20:14:35.190" v="1682" actId="20577"/>
@@ -200,14 +201,6 @@
           <pc:docMk/>
           <pc:sldMk cId="371781154" sldId="264"/>
         </pc:sldMkLst>
-        <pc:spChg chg="del">
-          <ac:chgData name="Antonio Anzora Jr" userId="0b7f19ef104c8f31" providerId="LiveId" clId="{728442DB-1AEA-44B8-B1D6-594786BBEB5D}" dt="2026-05-03T20:15:04.106" v="1683" actId="931"/>
-          <ac:spMkLst>
-            <pc:docMk/>
-            <pc:sldMk cId="371781154" sldId="264"/>
-            <ac:spMk id="3" creationId="{291B4F3B-34E2-60F7-F683-51B78AD24DF0}"/>
-          </ac:spMkLst>
-        </pc:spChg>
         <pc:spChg chg="add mod">
           <ac:chgData name="Antonio Anzora Jr" userId="0b7f19ef104c8f31" providerId="LiveId" clId="{728442DB-1AEA-44B8-B1D6-594786BBEB5D}" dt="2026-05-03T20:33:21.284" v="2871" actId="14100"/>
           <ac:spMkLst>
@@ -262,14 +255,6 @@
             <ac:spMk id="2" creationId="{8BDB0E4E-D867-9F30-2AA9-F74739CE9FF3}"/>
           </ac:spMkLst>
         </pc:spChg>
-        <pc:spChg chg="del">
-          <ac:chgData name="Antonio Anzora Jr" userId="0b7f19ef104c8f31" providerId="LiveId" clId="{728442DB-1AEA-44B8-B1D6-594786BBEB5D}" dt="2026-05-03T20:35:52.126" v="3082" actId="931"/>
-          <ac:spMkLst>
-            <pc:docMk/>
-            <pc:sldMk cId="4235160114" sldId="266"/>
-            <ac:spMk id="3" creationId="{E4FFE1FD-DA17-D888-3E22-22E655044DD8}"/>
-          </ac:spMkLst>
-        </pc:spChg>
         <pc:spChg chg="add mod">
           <ac:chgData name="Antonio Anzora Jr" userId="0b7f19ef104c8f31" providerId="LiveId" clId="{728442DB-1AEA-44B8-B1D6-594786BBEB5D}" dt="2026-05-03T20:38:03.750" v="3445" actId="1076"/>
           <ac:spMkLst>
@@ -278,22 +263,6 @@
             <ac:spMk id="7" creationId="{2551B54C-4A1C-FF98-CAC7-68FEB48BF09C}"/>
           </ac:spMkLst>
         </pc:spChg>
-        <pc:spChg chg="add del mod">
-          <ac:chgData name="Antonio Anzora Jr" userId="0b7f19ef104c8f31" providerId="LiveId" clId="{728442DB-1AEA-44B8-B1D6-594786BBEB5D}" dt="2026-05-03T20:38:29.801" v="3447" actId="931"/>
-          <ac:spMkLst>
-            <pc:docMk/>
-            <pc:sldMk cId="4235160114" sldId="266"/>
-            <ac:spMk id="9" creationId="{E65FB534-BB56-EDCC-161C-7A14EE0A8D64}"/>
-          </ac:spMkLst>
-        </pc:spChg>
-        <pc:picChg chg="add del mod ord">
-          <ac:chgData name="Antonio Anzora Jr" userId="0b7f19ef104c8f31" providerId="LiveId" clId="{728442DB-1AEA-44B8-B1D6-594786BBEB5D}" dt="2026-05-03T20:38:19.013" v="3446" actId="478"/>
-          <ac:picMkLst>
-            <pc:docMk/>
-            <pc:sldMk cId="4235160114" sldId="266"/>
-            <ac:picMk id="6" creationId="{F47D4145-0E32-3369-361D-637814BE556F}"/>
-          </ac:picMkLst>
-        </pc:picChg>
         <pc:picChg chg="add mod ord">
           <ac:chgData name="Antonio Anzora Jr" userId="0b7f19ef104c8f31" providerId="LiveId" clId="{728442DB-1AEA-44B8-B1D6-594786BBEB5D}" dt="2026-05-03T20:42:18.861" v="4125" actId="14100"/>
           <ac:picMkLst>
@@ -315,14 +284,6 @@
             <pc:docMk/>
             <pc:sldMk cId="339275679" sldId="267"/>
             <ac:spMk id="2" creationId="{E814A872-4C62-2D2E-F93B-D1D5CB9E599E}"/>
-          </ac:spMkLst>
-        </pc:spChg>
-        <pc:spChg chg="del">
-          <ac:chgData name="Antonio Anzora Jr" userId="0b7f19ef104c8f31" providerId="LiveId" clId="{728442DB-1AEA-44B8-B1D6-594786BBEB5D}" dt="2026-05-03T20:33:32.261" v="2872" actId="931"/>
-          <ac:spMkLst>
-            <pc:docMk/>
-            <pc:sldMk cId="339275679" sldId="267"/>
-            <ac:spMk id="3" creationId="{A3EA6B9B-29CA-1602-1BA0-CF106A2D3CD7}"/>
           </ac:spMkLst>
         </pc:spChg>
         <pc:spChg chg="add mod">
@@ -356,14 +317,6 @@
             <ac:spMk id="2" creationId="{6A66F4C9-E8F2-D9D7-5214-2567FC4095C1}"/>
           </ac:spMkLst>
         </pc:spChg>
-        <pc:spChg chg="del">
-          <ac:chgData name="Antonio Anzora Jr" userId="0b7f19ef104c8f31" providerId="LiveId" clId="{728442DB-1AEA-44B8-B1D6-594786BBEB5D}" dt="2026-05-03T20:45:13.977" v="4360" actId="931"/>
-          <ac:spMkLst>
-            <pc:docMk/>
-            <pc:sldMk cId="581494024" sldId="268"/>
-            <ac:spMk id="3" creationId="{84487297-59D2-B0FF-5FBA-F2A3F3742206}"/>
-          </ac:spMkLst>
-        </pc:spChg>
         <pc:spChg chg="add mod">
           <ac:chgData name="Antonio Anzora Jr" userId="0b7f19ef104c8f31" providerId="LiveId" clId="{728442DB-1AEA-44B8-B1D6-594786BBEB5D}" dt="2026-05-03T20:46:37.489" v="4562" actId="20577"/>
           <ac:spMkLst>
@@ -395,14 +348,6 @@
             <ac:spMk id="2" creationId="{06C5D53F-BE4C-3007-C63E-24546D60C5DA}"/>
           </ac:spMkLst>
         </pc:spChg>
-        <pc:spChg chg="del">
-          <ac:chgData name="Antonio Anzora Jr" userId="0b7f19ef104c8f31" providerId="LiveId" clId="{728442DB-1AEA-44B8-B1D6-594786BBEB5D}" dt="2026-05-03T20:42:27.732" v="4127" actId="931"/>
-          <ac:spMkLst>
-            <pc:docMk/>
-            <pc:sldMk cId="351193929" sldId="269"/>
-            <ac:spMk id="3" creationId="{E0831EB5-02CA-A854-75AF-8D649E22BD63}"/>
-          </ac:spMkLst>
-        </pc:spChg>
         <pc:spChg chg="add mod">
           <ac:chgData name="Antonio Anzora Jr" userId="0b7f19ef104c8f31" providerId="LiveId" clId="{728442DB-1AEA-44B8-B1D6-594786BBEB5D}" dt="2026-05-03T20:43:34.622" v="4358" actId="20577"/>
           <ac:spMkLst>
@@ -426,14 +371,6 @@
           <pc:docMk/>
           <pc:sldMk cId="2810775872" sldId="270"/>
         </pc:sldMkLst>
-        <pc:spChg chg="del">
-          <ac:chgData name="Antonio Anzora Jr" userId="0b7f19ef104c8f31" providerId="LiveId" clId="{728442DB-1AEA-44B8-B1D6-594786BBEB5D}" dt="2026-05-03T20:47:35.107" v="4800" actId="931"/>
-          <ac:spMkLst>
-            <pc:docMk/>
-            <pc:sldMk cId="2810775872" sldId="270"/>
-            <ac:spMk id="3" creationId="{C9210A22-F6CA-9A31-AF81-1316EA3A1DBA}"/>
-          </ac:spMkLst>
-        </pc:spChg>
         <pc:spChg chg="add mod">
           <ac:chgData name="Antonio Anzora Jr" userId="0b7f19ef104c8f31" providerId="LiveId" clId="{728442DB-1AEA-44B8-B1D6-594786BBEB5D}" dt="2026-05-03T20:51:53.179" v="5092"/>
           <ac:spMkLst>
@@ -474,20 +411,6 @@
           </ac:spMkLst>
         </pc:spChg>
       </pc:sldChg>
-      <pc:sldChg chg="del">
-        <pc:chgData name="Antonio Anzora Jr" userId="0b7f19ef104c8f31" providerId="LiveId" clId="{728442DB-1AEA-44B8-B1D6-594786BBEB5D}" dt="2026-05-03T20:19:33.262" v="2125" actId="47"/>
-        <pc:sldMkLst>
-          <pc:docMk/>
-          <pc:sldMk cId="3972590324" sldId="272"/>
-        </pc:sldMkLst>
-      </pc:sldChg>
-      <pc:sldChg chg="del">
-        <pc:chgData name="Antonio Anzora Jr" userId="0b7f19ef104c8f31" providerId="LiveId" clId="{728442DB-1AEA-44B8-B1D6-594786BBEB5D}" dt="2026-05-03T20:19:37.503" v="2126" actId="47"/>
-        <pc:sldMkLst>
-          <pc:docMk/>
-          <pc:sldMk cId="461504658" sldId="273"/>
-        </pc:sldMkLst>
-      </pc:sldChg>
     </pc:docChg>
   </pc:docChgLst>
 </pc:chgInfo>
@@ -575,7 +498,7 @@
           <a:p>
             <a:fld id="{16A18D26-10E9-461C-9FE6-798C6E0BAAF0}" type="datetimeFigureOut">
               <a:rPr lang="en-US" smtClean="0"/>
-              <a:t>5/3/2026</a:t>
+              <a:t>5/6/2026</a:t>
             </a:fld>
             <a:endParaRPr lang="en-US"/>
           </a:p>
@@ -973,6 +896,231 @@
           <a:bodyPr/>
           <a:lstStyle/>
           <a:p>
+            <a:r>
+              <a:rPr lang="en-US" dirty="0"/>
+              <a:t>This is the complete pipeline executing three instructions: ADDI, LW, and ADD. Let me walk you through what's happening.</a:t>
+            </a:r>
+          </a:p>
+          <a:p>
+            <a:r>
+              <a:rPr lang="en-US" dirty="0"/>
+              <a:t>First, look at </a:t>
+            </a:r>
+            <a:r>
+              <a:rPr lang="en-US" sz="1200" kern="1200" dirty="0" err="1">
+                <a:solidFill>
+                  <a:schemeClr val="tx1"/>
+                </a:solidFill>
+                <a:latin typeface="+mn-lt"/>
+                <a:ea typeface="+mn-ea"/>
+                <a:cs typeface="+mn-cs"/>
+              </a:rPr>
+              <a:t>instructionInput_TB</a:t>
+            </a:r>
+            <a:r>
+              <a:rPr lang="en-US" dirty="0"/>
+              <a:t> — you see three different instruction values being fed in at different times. That's ADDI, then LW, then ADD.</a:t>
+            </a:r>
+          </a:p>
+          <a:p>
+            <a:r>
+              <a:rPr lang="en-US" dirty="0"/>
+              <a:t>Now watch the key signals: </a:t>
+            </a:r>
+            <a:r>
+              <a:rPr lang="en-US" sz="1200" kern="1200" dirty="0" err="1">
+                <a:solidFill>
+                  <a:schemeClr val="tx1"/>
+                </a:solidFill>
+                <a:latin typeface="+mn-lt"/>
+                <a:ea typeface="+mn-ea"/>
+                <a:cs typeface="+mn-cs"/>
+              </a:rPr>
+              <a:t>cdbValid</a:t>
+            </a:r>
+            <a:r>
+              <a:rPr lang="en-US" dirty="0"/>
+              <a:t> and </a:t>
+            </a:r>
+            <a:r>
+              <a:rPr lang="en-US" sz="1200" kern="1200" dirty="0" err="1">
+                <a:solidFill>
+                  <a:schemeClr val="tx1"/>
+                </a:solidFill>
+                <a:latin typeface="+mn-lt"/>
+                <a:ea typeface="+mn-ea"/>
+                <a:cs typeface="+mn-cs"/>
+              </a:rPr>
+              <a:t>cdbTag</a:t>
+            </a:r>
+            <a:r>
+              <a:rPr lang="en-US" dirty="0"/>
+              <a:t>. Notice that </a:t>
+            </a:r>
+            <a:r>
+              <a:rPr lang="en-US" sz="1200" kern="1200" dirty="0" err="1">
+                <a:solidFill>
+                  <a:schemeClr val="tx1"/>
+                </a:solidFill>
+                <a:latin typeface="+mn-lt"/>
+                <a:ea typeface="+mn-ea"/>
+                <a:cs typeface="+mn-cs"/>
+              </a:rPr>
+              <a:t>cdbValid</a:t>
+            </a:r>
+            <a:r>
+              <a:rPr lang="en-US" dirty="0"/>
+              <a:t> pulses (goes high) at </a:t>
+            </a:r>
+            <a:r>
+              <a:rPr lang="en-US" b="1" dirty="0"/>
+              <a:t>different times</a:t>
+            </a:r>
+            <a:r>
+              <a:rPr lang="en-US" dirty="0"/>
+              <a:t> — around 80ns, then 120ns, then 180ns. That means different instructions are finishing execution at different times. </a:t>
+            </a:r>
+            <a:r>
+              <a:rPr lang="en-US" b="1" dirty="0"/>
+              <a:t>That's out-of-order execution.</a:t>
+            </a:r>
+            <a:endParaRPr lang="en-US" dirty="0"/>
+          </a:p>
+          <a:p>
+            <a:r>
+              <a:rPr lang="en-US" dirty="0"/>
+              <a:t>But here's the magic: look at </a:t>
+            </a:r>
+            <a:r>
+              <a:rPr lang="en-US" sz="1200" kern="1200" dirty="0" err="1">
+                <a:solidFill>
+                  <a:schemeClr val="tx1"/>
+                </a:solidFill>
+                <a:latin typeface="+mn-lt"/>
+                <a:ea typeface="+mn-ea"/>
+                <a:cs typeface="+mn-cs"/>
+              </a:rPr>
+              <a:t>commitEnable</a:t>
+            </a:r>
+            <a:r>
+              <a:rPr lang="en-US" dirty="0"/>
+              <a:t> — it pulses </a:t>
+            </a:r>
+            <a:r>
+              <a:rPr lang="en-US" b="1" dirty="0"/>
+              <a:t>sequentially</a:t>
+            </a:r>
+            <a:r>
+              <a:rPr lang="en-US" dirty="0"/>
+              <a:t>. One pulse, then the next, then the next. And </a:t>
+            </a:r>
+            <a:r>
+              <a:rPr lang="en-US" sz="1200" kern="1200" dirty="0" err="1">
+                <a:solidFill>
+                  <a:schemeClr val="tx1"/>
+                </a:solidFill>
+                <a:latin typeface="+mn-lt"/>
+                <a:ea typeface="+mn-ea"/>
+                <a:cs typeface="+mn-cs"/>
+              </a:rPr>
+              <a:t>cdbTag</a:t>
+            </a:r>
+            <a:r>
+              <a:rPr lang="en-US" dirty="0"/>
+              <a:t> shows the sequence: 0000, then 0100, then 0000. The instructions commit in program order, even though they executed out of order.</a:t>
+            </a:r>
+          </a:p>
+          <a:p>
+            <a:r>
+              <a:rPr lang="en-US" dirty="0"/>
+              <a:t>This is Tomasulo's Algorithm working. Instructions execute whenever their operands are ready, not in program order. But they commit to the register file in program order, maintaining correctness. That's why it's safe, and that's why it's fast."</a:t>
+            </a:r>
+          </a:p>
+          <a:p>
+            <a:endParaRPr lang="en-US" dirty="0"/>
+          </a:p>
+        </p:txBody>
+      </p:sp>
+      <p:sp>
+        <p:nvSpPr>
+          <p:cNvPr id="4" name="Slide Number Placeholder 3"/>
+          <p:cNvSpPr>
+            <a:spLocks noGrp="1"/>
+          </p:cNvSpPr>
+          <p:nvPr>
+            <p:ph type="sldNum" sz="quarter" idx="5"/>
+          </p:nvPr>
+        </p:nvSpPr>
+        <p:spPr/>
+        <p:txBody>
+          <a:bodyPr/>
+          <a:lstStyle/>
+          <a:p>
+            <a:fld id="{FA051D29-8EA3-42D3-BB95-BE917086C5B1}" type="slidenum">
+              <a:rPr lang="en-US" smtClean="0"/>
+              <a:t>11</a:t>
+            </a:fld>
+            <a:endParaRPr lang="en-US"/>
+          </a:p>
+        </p:txBody>
+      </p:sp>
+    </p:spTree>
+    <p:extLst>
+      <p:ext uri="{BB962C8B-B14F-4D97-AF65-F5344CB8AC3E}">
+        <p14:creationId xmlns:p14="http://schemas.microsoft.com/office/powerpoint/2010/main" val="3295559901"/>
+      </p:ext>
+    </p:extLst>
+  </p:cSld>
+  <p:clrMapOvr>
+    <a:masterClrMapping/>
+  </p:clrMapOvr>
+</p:notes>
+</file>
+
+<file path=ppt/notesSlides/notesSlide11.xml><?xml version="1.0" encoding="utf-8"?>
+<p:notes xmlns:a="http://schemas.openxmlformats.org/drawingml/2006/main" xmlns:r="http://schemas.openxmlformats.org/officeDocument/2006/relationships" xmlns:p="http://schemas.openxmlformats.org/presentationml/2006/main">
+  <p:cSld>
+    <p:spTree>
+      <p:nvGrpSpPr>
+        <p:cNvPr id="1" name=""/>
+        <p:cNvGrpSpPr/>
+        <p:nvPr/>
+      </p:nvGrpSpPr>
+      <p:grpSpPr>
+        <a:xfrm>
+          <a:off x="0" y="0"/>
+          <a:ext cx="0" cy="0"/>
+          <a:chOff x="0" y="0"/>
+          <a:chExt cx="0" cy="0"/>
+        </a:xfrm>
+      </p:grpSpPr>
+      <p:sp>
+        <p:nvSpPr>
+          <p:cNvPr id="2" name="Slide Image Placeholder 1"/>
+          <p:cNvSpPr>
+            <a:spLocks noGrp="1" noRot="1" noChangeAspect="1"/>
+          </p:cNvSpPr>
+          <p:nvPr>
+            <p:ph type="sldImg"/>
+          </p:nvPr>
+        </p:nvSpPr>
+        <p:spPr/>
+      </p:sp>
+      <p:sp>
+        <p:nvSpPr>
+          <p:cNvPr id="3" name="Notes Placeholder 2"/>
+          <p:cNvSpPr>
+            <a:spLocks noGrp="1"/>
+          </p:cNvSpPr>
+          <p:nvPr>
+            <p:ph type="body" idx="1"/>
+          </p:nvPr>
+        </p:nvSpPr>
+        <p:spPr/>
+        <p:txBody>
+          <a:bodyPr/>
+          <a:lstStyle/>
+          <a:p>
             <a:endParaRPr lang="en-US" dirty="0"/>
           </a:p>
         </p:txBody>
@@ -1059,13 +1207,65 @@
           <a:p>
             <a:r>
               <a:rPr lang="en-US" dirty="0"/>
-              <a:t>Modern processors can’t afford to stall on every data dependency. If instruction 2 depends on instruction 1, why wait? Tomasulo lets instruction 3 first if its operands are ready</a:t>
-            </a:r>
-          </a:p>
-          <a:p>
-            <a:r>
-              <a:rPr lang="en-US" dirty="0"/>
-              <a:t>This is how Intel, AMD, and apple get high performance.</a:t>
+              <a:t>Let me explain why out-of-order execution matters.</a:t>
+            </a:r>
+          </a:p>
+          <a:p>
+            <a:r>
+              <a:rPr lang="en-US" b="1" dirty="0"/>
+              <a:t>In-order execution wastes cycles waiting for dependencies.</a:t>
+            </a:r>
+            <a:endParaRPr lang="en-US" dirty="0"/>
+          </a:p>
+          <a:p>
+            <a:r>
+              <a:rPr lang="en-US" dirty="0"/>
+              <a:t>Imagine you have three instructions. Instruction 1 adds two numbers and stores the result in register x1. Instruction 2 needs that result — it can't execute until instruction 1 finishes. So instruction 2 stalls and waits.</a:t>
+            </a:r>
+          </a:p>
+          <a:p>
+            <a:r>
+              <a:rPr lang="en-US" dirty="0"/>
+              <a:t>Meanwhile, instruction 3 doesn't depend on anything. It's ready to go right now. But in an in-order processor, instruction 3 has to wait behind instruction 2. It sits idle. That's wasted processing power.</a:t>
+            </a:r>
+          </a:p>
+          <a:p>
+            <a:r>
+              <a:rPr lang="en-US" b="1" dirty="0"/>
+              <a:t>Modern CPUs execute 3-4 instructions per cycle.</a:t>
+            </a:r>
+            <a:endParaRPr lang="en-US" dirty="0"/>
+          </a:p>
+          <a:p>
+            <a:r>
+              <a:rPr lang="en-US" dirty="0"/>
+              <a:t>That means the processor has multiple execution units working in parallel. An ALU, a memory unit, maybe more. They can all work at the same time. But if we're waiting for dependencies, we're not using all that hardware. We're leaving performance on the table.</a:t>
+            </a:r>
+          </a:p>
+          <a:p>
+            <a:r>
+              <a:rPr lang="en-US" b="1" dirty="0"/>
+              <a:t>Out-of-order execution allows instructions to execute based on data availability.</a:t>
+            </a:r>
+            <a:endParaRPr lang="en-US" dirty="0"/>
+          </a:p>
+          <a:p>
+            <a:r>
+              <a:rPr lang="en-US" dirty="0"/>
+              <a:t>Instead of waiting for program order, we execute whichever instruction is ready. If instruction 3 has its operands ready, it goes now. Don't wait for instruction 2.</a:t>
+            </a:r>
+          </a:p>
+          <a:p>
+            <a:r>
+              <a:rPr lang="en-US" b="1" dirty="0"/>
+              <a:t>This reduces cycle time.</a:t>
+            </a:r>
+            <a:endParaRPr lang="en-US" dirty="0"/>
+          </a:p>
+          <a:p>
+            <a:r>
+              <a:rPr lang="en-US" dirty="0"/>
+              <a:t>More instructions finish per cycle. Faster performance. That's why modern CPUs use it.</a:t>
             </a:r>
           </a:p>
           <a:p>
@@ -1155,7 +1355,64 @@
           <a:p>
             <a:r>
               <a:rPr lang="en-US" dirty="0"/>
-              <a:t>The key insight is that Reservation Stations buffer operands locally. They don’t need global tracking. Each RS watches the CDB and grabs results when they appear.</a:t>
+              <a:t>Tomasulo's Algorithm has three stages. Let me break down each one simply.</a:t>
+            </a:r>
+          </a:p>
+          <a:p>
+            <a:r>
+              <a:rPr lang="en-US" b="1" dirty="0"/>
+              <a:t>Stage 1: ISSUE</a:t>
+            </a:r>
+            <a:endParaRPr lang="en-US" dirty="0"/>
+          </a:p>
+          <a:p>
+            <a:r>
+              <a:rPr lang="en-US" dirty="0"/>
+              <a:t>An instruction comes in. We check: are both operands ready right now? If yes, send it to the Reservation Station immediately with both values. If no — if one operand is still being computed — send it to the RS anyway, but without that operand. The RS will wait for it.</a:t>
+            </a:r>
+          </a:p>
+          <a:p>
+            <a:r>
+              <a:rPr lang="en-US" b="1" dirty="0"/>
+              <a:t>Stage 2: EXECUTE</a:t>
+            </a:r>
+            <a:endParaRPr lang="en-US" dirty="0"/>
+          </a:p>
+          <a:p>
+            <a:r>
+              <a:rPr lang="en-US" dirty="0"/>
+              <a:t>The instruction sits in the RS waiting. Meanwhile, other instructions are finishing their execution. Their results broadcast on the CDB — the Common Data Bus.</a:t>
+            </a:r>
+          </a:p>
+          <a:p>
+            <a:r>
+              <a:rPr lang="en-US" dirty="0"/>
+              <a:t>The RS watches the CDB. When a result appears that it's waiting for, it grabs it. Once both operands are there, the instruction executes right away.</a:t>
+            </a:r>
+          </a:p>
+          <a:p>
+            <a:r>
+              <a:rPr lang="en-US" dirty="0"/>
+              <a:t>This is the magic: different instructions get their operands at different times. So they execute at different times. Out of order.</a:t>
+            </a:r>
+          </a:p>
+          <a:p>
+            <a:r>
+              <a:rPr lang="en-US" b="1" dirty="0"/>
+              <a:t>Stage 3: WRITE RESULT</a:t>
+            </a:r>
+            <a:endParaRPr lang="en-US" dirty="0"/>
+          </a:p>
+          <a:p>
+            <a:r>
+              <a:rPr lang="en-US" dirty="0"/>
+              <a:t>The instruction finishes. The result broadcasts on the CDB with a tag that says which instruction it's for. The ROB marks that instruction as done. And when it's that instruction's turn in program order, the result gets written to the register file.</a:t>
+            </a:r>
+          </a:p>
+          <a:p>
+            <a:r>
+              <a:rPr lang="en-US" dirty="0"/>
+              <a:t>That's it. Three stages. The key is the RS and CDB working together — they let instructions execute whenever they're ready, not in order.</a:t>
             </a:r>
           </a:p>
         </p:txBody>
@@ -1335,130 +1592,88 @@
           <a:p>
             <a:r>
               <a:rPr lang="en-US" dirty="0"/>
-              <a:t>The register file is the foundation. It has dual-port capability, two simultaneous writes and reads. This is essential for issuing instructions with two operands in parallel.</a:t>
-            </a:r>
-          </a:p>
-          <a:p>
-            <a:endParaRPr lang="en-US" dirty="0"/>
-          </a:p>
-          <a:p>
-            <a:r>
-              <a:rPr lang="en-US" dirty="0"/>
-              <a:t>"This is the Register File simulation. The Register File is basically the processor's memory for temporary storage. Each register holds a 32-bit value.</a:t>
-            </a:r>
-          </a:p>
-          <a:p>
-            <a:r>
-              <a:rPr lang="en-US" dirty="0"/>
-              <a:t>Look at the waveform. You see </a:t>
-            </a:r>
-            <a:r>
-              <a:rPr lang="en-US" sz="1200" kern="1200" dirty="0">
-                <a:solidFill>
-                  <a:schemeClr val="tx1"/>
-                </a:solidFill>
-                <a:latin typeface="+mn-lt"/>
-                <a:ea typeface="+mn-ea"/>
-                <a:cs typeface="+mn-cs"/>
-              </a:rPr>
-              <a:t>WriteReg1_TB</a:t>
-            </a:r>
-            <a:r>
-              <a:rPr lang="en-US" dirty="0"/>
-              <a:t> and </a:t>
-            </a:r>
-            <a:r>
-              <a:rPr lang="en-US" sz="1200" kern="1200" dirty="0">
-                <a:solidFill>
-                  <a:schemeClr val="tx1"/>
-                </a:solidFill>
-                <a:latin typeface="+mn-lt"/>
-                <a:ea typeface="+mn-ea"/>
-                <a:cs typeface="+mn-cs"/>
-              </a:rPr>
-              <a:t>WriteReg2_TB</a:t>
-            </a:r>
-            <a:r>
-              <a:rPr lang="en-US" dirty="0"/>
-              <a:t> — these specify which registers we're writing to. At 40ns, we write to register x1. At 60ns, we write to register x2. Notice they're happening at the same time — that's the dual-port capability. Two writes in parallel.</a:t>
-            </a:r>
-          </a:p>
-          <a:p>
-            <a:r>
-              <a:rPr lang="en-US" dirty="0"/>
-              <a:t>Then look at </a:t>
-            </a:r>
-            <a:r>
-              <a:rPr lang="en-US" sz="1200" kern="1200" dirty="0">
-                <a:solidFill>
-                  <a:schemeClr val="tx1"/>
-                </a:solidFill>
-                <a:latin typeface="+mn-lt"/>
-                <a:ea typeface="+mn-ea"/>
-                <a:cs typeface="+mn-cs"/>
-              </a:rPr>
-              <a:t>WriteData1_TB</a:t>
-            </a:r>
-            <a:r>
-              <a:rPr lang="en-US" dirty="0"/>
-              <a:t> and </a:t>
-            </a:r>
-            <a:r>
-              <a:rPr lang="en-US" sz="1200" kern="1200" dirty="0">
-                <a:solidFill>
-                  <a:schemeClr val="tx1"/>
-                </a:solidFill>
-                <a:latin typeface="+mn-lt"/>
-                <a:ea typeface="+mn-ea"/>
-                <a:cs typeface="+mn-cs"/>
-              </a:rPr>
-              <a:t>WriteData2_TB</a:t>
-            </a:r>
-            <a:r>
-              <a:rPr lang="en-US" dirty="0"/>
-              <a:t> — these are the values being written. You can see they change as we write to different registers.</a:t>
-            </a:r>
-          </a:p>
-          <a:p>
-            <a:r>
-              <a:rPr lang="en-US" dirty="0"/>
-              <a:t>Finally, </a:t>
-            </a:r>
-            <a:r>
-              <a:rPr lang="en-US" sz="1200" kern="1200" dirty="0">
-                <a:solidFill>
-                  <a:schemeClr val="tx1"/>
-                </a:solidFill>
-                <a:latin typeface="+mn-lt"/>
-                <a:ea typeface="+mn-ea"/>
-                <a:cs typeface="+mn-cs"/>
-              </a:rPr>
-              <a:t>ReadReg1_TB</a:t>
-            </a:r>
-            <a:r>
-              <a:rPr lang="en-US" dirty="0"/>
-              <a:t> and </a:t>
-            </a:r>
-            <a:r>
-              <a:rPr lang="en-US" sz="1200" kern="1200" dirty="0">
-                <a:solidFill>
-                  <a:schemeClr val="tx1"/>
-                </a:solidFill>
-                <a:latin typeface="+mn-lt"/>
-                <a:ea typeface="+mn-ea"/>
-                <a:cs typeface="+mn-cs"/>
-              </a:rPr>
-              <a:t>ReadReg2_TB</a:t>
-            </a:r>
-            <a:r>
-              <a:rPr lang="en-US" dirty="0"/>
-              <a:t> show reads happening around 100-120ns. The read data comes back correctly.</a:t>
-            </a:r>
-          </a:p>
-          <a:p>
-            <a:r>
-              <a:rPr lang="en-US" dirty="0"/>
-              <a:t>Why does this matter? Because when we issue two instructions simultaneously, they both need to read their operands at the same time. The dual-port read capability makes that possible."</a:t>
+              <a:t>Three components make Tomasulo work. Let me explain each one simply.</a:t>
+            </a:r>
+          </a:p>
+          <a:p>
+            <a:r>
+              <a:rPr lang="en-US" b="1" dirty="0"/>
+              <a:t>RAT — Register Alias Table</a:t>
+            </a:r>
+            <a:endParaRPr lang="en-US" dirty="0"/>
+          </a:p>
+          <a:p>
+            <a:r>
+              <a:rPr lang="en-US" dirty="0"/>
+              <a:t>Here's the problem: two instructions both write to register x1. That's a conflict. The RAT solves it by renaming.</a:t>
+            </a:r>
+          </a:p>
+          <a:p>
+            <a:r>
+              <a:rPr lang="en-US" dirty="0"/>
+              <a:t>When instruction 1 writes to x1, the RAT says 'you're actually writing to ROB slot 3.' When instruction 2 writes to x1, it says 'you're writing to ROB slot 5.' Now they don't conflict. Different slots, no problem.</a:t>
+            </a:r>
+          </a:p>
+          <a:p>
+            <a:r>
+              <a:rPr lang="en-US" dirty="0"/>
+              <a:t>Why does this matter? Because now both instructions can execute in parallel without stepping on each other. The RAT eliminates false dependencies.</a:t>
+            </a:r>
+          </a:p>
+          <a:p>
+            <a:r>
+              <a:rPr lang="en-US" b="1" dirty="0"/>
+              <a:t>Reservation Stations — RS</a:t>
+            </a:r>
+            <a:endParaRPr lang="en-US" dirty="0"/>
+          </a:p>
+          <a:p>
+            <a:r>
+              <a:rPr lang="en-US" dirty="0"/>
+              <a:t>The RS is a waiting room for instructions. When an instruction arrives and one operand isn't ready, it waits here.</a:t>
+            </a:r>
+          </a:p>
+          <a:p>
+            <a:r>
+              <a:rPr lang="en-US" dirty="0"/>
+              <a:t>But while it's waiting, other instructions can keep moving. The RS watches the CDB — the result bus. When a result it needs appears, it grabs it.</a:t>
+            </a:r>
+          </a:p>
+          <a:p>
+            <a:r>
+              <a:rPr lang="en-US" dirty="0"/>
+              <a:t>Once it has both operands, it executes immediately. No waiting in line. No program order. Whichever instruction is ready goes first. This is where out-of-order execution actually happens.</a:t>
+            </a:r>
+          </a:p>
+          <a:p>
+            <a:r>
+              <a:rPr lang="en-US" b="1" dirty="0"/>
+              <a:t>ROB — Reorder Buffer</a:t>
+            </a:r>
+            <a:endParaRPr lang="en-US" dirty="0"/>
+          </a:p>
+          <a:p>
+            <a:r>
+              <a:rPr lang="en-US" dirty="0"/>
+              <a:t>The ROB is the safety net. Even though instructions execute out of order, the ROB makes sure they commit in order.</a:t>
+            </a:r>
+          </a:p>
+          <a:p>
+            <a:r>
+              <a:rPr lang="en-US" dirty="0"/>
+              <a:t>Instructions enter in order: slot 1, slot 2, slot 3. They execute at different times. But they commit in order — slot 1 first, then slot 2, then slot 3. Results go to the register file in program order.</a:t>
+            </a:r>
+          </a:p>
+          <a:p>
+            <a:r>
+              <a:rPr lang="en-US" dirty="0"/>
+              <a:t>This is why it's safe. The processor looks like it executed sequentially to the outside world. But internally, we got the speed of out-of-order execution.</a:t>
+            </a:r>
+          </a:p>
+          <a:p>
+            <a:r>
+              <a:rPr lang="en-US" dirty="0"/>
+              <a:t>That's the magic: RAT removes conflicts, RS executes dynamically, ROB commits safely</a:t>
             </a:r>
           </a:p>
           <a:p>
@@ -1483,7 +1698,7 @@
           <a:p>
             <a:fld id="{FA051D29-8EA3-42D3-BB95-BE917086C5B1}" type="slidenum">
               <a:rPr lang="en-US" smtClean="0"/>
-              <a:t>7</a:t>
+              <a:t>6</a:t>
             </a:fld>
             <a:endParaRPr lang="en-US"/>
           </a:p>
@@ -1492,7 +1707,7 @@
     </p:spTree>
     <p:extLst>
       <p:ext uri="{BB962C8B-B14F-4D97-AF65-F5344CB8AC3E}">
-        <p14:creationId xmlns:p14="http://schemas.microsoft.com/office/powerpoint/2010/main" val="3989171361"/>
+        <p14:creationId xmlns:p14="http://schemas.microsoft.com/office/powerpoint/2010/main" val="3709056794"/>
       </p:ext>
     </p:extLst>
   </p:cSld>
@@ -1548,39 +1763,22 @@
           <a:p>
             <a:r>
               <a:rPr lang="en-US" dirty="0"/>
-              <a:t>The RAT maps registers to in-flight ROB entries. This is register renaming. Now when instruction 1 writes x1, and instruction 3 also writes x1, there’s no conflict they get different ROB entries.</a:t>
-            </a:r>
-          </a:p>
-          <a:p>
-            <a:endParaRPr lang="en-US" dirty="0"/>
-          </a:p>
-          <a:p>
-            <a:r>
-              <a:rPr lang="en-US" dirty="0"/>
-              <a:t>"This is the Register Alias Table — the RAT. The RAT is the key to register renaming.</a:t>
-            </a:r>
-          </a:p>
-          <a:p>
-            <a:r>
-              <a:rPr lang="en-US" dirty="0"/>
-              <a:t>Think of it like a mapping table. When an instruction writes to a register, the RAT says 'Okay, x1 is now being written by ROB entry 0011.' When another instruction writes to x1, the RAT updates: 'x1 is now being written by ROB entry 0101.' No conflict.</a:t>
-            </a:r>
-          </a:p>
-          <a:p>
-            <a:r>
-              <a:rPr lang="en-US" dirty="0"/>
-              <a:t>Look at </a:t>
-            </a:r>
-            <a:r>
-              <a:rPr lang="en-US" sz="1200" kern="1200" dirty="0" err="1">
-                <a:solidFill>
-                  <a:schemeClr val="tx1"/>
-                </a:solidFill>
-                <a:latin typeface="+mn-lt"/>
-                <a:ea typeface="+mn-ea"/>
-                <a:cs typeface="+mn-cs"/>
-              </a:rPr>
-              <a:t>WriteRegister_TB</a:t>
+              <a:t>The register file is the foundation. It has dual-port capability, two simultaneous writes and reads. This is essential for issuing instructions with two operands in parallel.</a:t>
+            </a:r>
+          </a:p>
+          <a:p>
+            <a:endParaRPr lang="en-US" dirty="0"/>
+          </a:p>
+          <a:p>
+            <a:r>
+              <a:rPr lang="en-US" dirty="0"/>
+              <a:t>"This is the Register File simulation. The Register File is basically the processor's memory for temporary storage. Each register holds a 32-bit value.</a:t>
+            </a:r>
+          </a:p>
+          <a:p>
+            <a:r>
+              <a:rPr lang="en-US" dirty="0"/>
+              <a:t>Look at the waveform. You see </a:t>
             </a:r>
             <a:r>
               <a:rPr lang="en-US" sz="1200" kern="1200" dirty="0">
@@ -1591,22 +1789,11 @@
                 <a:ea typeface="+mn-ea"/>
                 <a:cs typeface="+mn-cs"/>
               </a:rPr>
-              <a:t>[4:0]</a:t>
-            </a:r>
-            <a:r>
-              <a:rPr lang="en-US" dirty="0"/>
-              <a:t> — that's the register being written (x0, x1, x2, etc.). Look at </a:t>
-            </a:r>
-            <a:r>
-              <a:rPr lang="en-US" sz="1200" kern="1200" dirty="0" err="1">
-                <a:solidFill>
-                  <a:schemeClr val="tx1"/>
-                </a:solidFill>
-                <a:latin typeface="+mn-lt"/>
-                <a:ea typeface="+mn-ea"/>
-                <a:cs typeface="+mn-cs"/>
-              </a:rPr>
-              <a:t>WriteTag_TB</a:t>
+              <a:t>WriteReg1_TB</a:t>
+            </a:r>
+            <a:r>
+              <a:rPr lang="en-US" dirty="0"/>
+              <a:t> and </a:t>
             </a:r>
             <a:r>
               <a:rPr lang="en-US" sz="1200" kern="1200" dirty="0">
@@ -1617,23 +1804,89 @@
                 <a:ea typeface="+mn-ea"/>
                 <a:cs typeface="+mn-cs"/>
               </a:rPr>
-              <a:t>[3:0]</a:t>
-            </a:r>
-            <a:r>
-              <a:rPr lang="en-US" dirty="0"/>
-              <a:t> — that's the ROB entry number.</a:t>
-            </a:r>
-          </a:p>
-          <a:p>
-            <a:r>
-              <a:rPr lang="en-US" dirty="0"/>
-              <a:t>At 20ns, we write x1 with tag 0000. At 40ns, we write x1 again with tag 0001. The RAT tracks both. Now when instruction 1 reads x1, it gets ROB entry 0000. When instruction 2 reads x1, it gets ROB entry 0001. Different ROB entries, no conflict.</a:t>
-            </a:r>
-          </a:p>
-          <a:p>
-            <a:r>
-              <a:rPr lang="en-US" dirty="0"/>
-              <a:t>This is register renaming. It eliminates false data dependencies and lets instructions execute out of order without conflicts."</a:t>
+              <a:t>WriteReg2_TB</a:t>
+            </a:r>
+            <a:r>
+              <a:rPr lang="en-US" dirty="0"/>
+              <a:t> — these specify which registers we're writing to. At 40ns, we write to register x1. At 60ns, we write to register x2. Notice they're happening at the same time — that's the dual-port capability. Two writes in parallel.</a:t>
+            </a:r>
+          </a:p>
+          <a:p>
+            <a:r>
+              <a:rPr lang="en-US" dirty="0"/>
+              <a:t>Then look at </a:t>
+            </a:r>
+            <a:r>
+              <a:rPr lang="en-US" sz="1200" kern="1200" dirty="0">
+                <a:solidFill>
+                  <a:schemeClr val="tx1"/>
+                </a:solidFill>
+                <a:latin typeface="+mn-lt"/>
+                <a:ea typeface="+mn-ea"/>
+                <a:cs typeface="+mn-cs"/>
+              </a:rPr>
+              <a:t>WriteData1_TB</a:t>
+            </a:r>
+            <a:r>
+              <a:rPr lang="en-US" dirty="0"/>
+              <a:t> and </a:t>
+            </a:r>
+            <a:r>
+              <a:rPr lang="en-US" sz="1200" kern="1200" dirty="0">
+                <a:solidFill>
+                  <a:schemeClr val="tx1"/>
+                </a:solidFill>
+                <a:latin typeface="+mn-lt"/>
+                <a:ea typeface="+mn-ea"/>
+                <a:cs typeface="+mn-cs"/>
+              </a:rPr>
+              <a:t>WriteData2_TB</a:t>
+            </a:r>
+            <a:r>
+              <a:rPr lang="en-US" dirty="0"/>
+              <a:t> — these are the values being written. You can see they change as we write to different registers.</a:t>
+            </a:r>
+          </a:p>
+          <a:p>
+            <a:r>
+              <a:rPr lang="en-US" dirty="0"/>
+              <a:t>Finally, </a:t>
+            </a:r>
+            <a:r>
+              <a:rPr lang="en-US" sz="1200" kern="1200" dirty="0">
+                <a:solidFill>
+                  <a:schemeClr val="tx1"/>
+                </a:solidFill>
+                <a:latin typeface="+mn-lt"/>
+                <a:ea typeface="+mn-ea"/>
+                <a:cs typeface="+mn-cs"/>
+              </a:rPr>
+              <a:t>ReadReg1_TB</a:t>
+            </a:r>
+            <a:r>
+              <a:rPr lang="en-US" dirty="0"/>
+              <a:t> and </a:t>
+            </a:r>
+            <a:r>
+              <a:rPr lang="en-US" sz="1200" kern="1200" dirty="0">
+                <a:solidFill>
+                  <a:schemeClr val="tx1"/>
+                </a:solidFill>
+                <a:latin typeface="+mn-lt"/>
+                <a:ea typeface="+mn-ea"/>
+                <a:cs typeface="+mn-cs"/>
+              </a:rPr>
+              <a:t>ReadReg2_TB</a:t>
+            </a:r>
+            <a:r>
+              <a:rPr lang="en-US" dirty="0"/>
+              <a:t> show reads happening around 100-120ns. The read data comes back correctly.</a:t>
+            </a:r>
+          </a:p>
+          <a:p>
+            <a:r>
+              <a:rPr lang="en-US" dirty="0"/>
+              <a:t>Why does this matter? Because when we issue two instructions simultaneously, they both need to read their operands at the same time. The dual-port read capability makes that possible."</a:t>
             </a:r>
           </a:p>
           <a:p>
@@ -1658,7 +1911,7 @@
           <a:p>
             <a:fld id="{FA051D29-8EA3-42D3-BB95-BE917086C5B1}" type="slidenum">
               <a:rPr lang="en-US" smtClean="0"/>
-              <a:t>8</a:t>
+              <a:t>7</a:t>
             </a:fld>
             <a:endParaRPr lang="en-US"/>
           </a:p>
@@ -1667,7 +1920,7 @@
     </p:spTree>
     <p:extLst>
       <p:ext uri="{BB962C8B-B14F-4D97-AF65-F5344CB8AC3E}">
-        <p14:creationId xmlns:p14="http://schemas.microsoft.com/office/powerpoint/2010/main" val="2966007745"/>
+        <p14:creationId xmlns:p14="http://schemas.microsoft.com/office/powerpoint/2010/main" val="3989171361"/>
       </p:ext>
     </p:extLst>
   </p:cSld>
@@ -1723,16 +1976,22 @@
           <a:p>
             <a:r>
               <a:rPr lang="en-US" dirty="0"/>
-              <a:t>Here’s when out-of-order execution actually happens. The second instruction has to wait for an operand, but the third instruction doesn’t. The third can execute first. RS watches the CDB, and as soon as its operand appears its ready to go.</a:t>
-            </a:r>
-          </a:p>
-          <a:p>
-            <a:endParaRPr lang="en-US" dirty="0"/>
-          </a:p>
-          <a:p>
-            <a:r>
-              <a:rPr lang="en-US" dirty="0"/>
-              <a:t>The Reservation Station is where instructions wait for their operands and where out-of-order execution happens.</a:t>
+              <a:t>The RAT maps registers to in-flight ROB entries. This is register renaming. Now when instruction 1 writes x1, and instruction 3 also writes x1, there’s no conflict they get different ROB entries.</a:t>
+            </a:r>
+          </a:p>
+          <a:p>
+            <a:endParaRPr lang="en-US" dirty="0"/>
+          </a:p>
+          <a:p>
+            <a:r>
+              <a:rPr lang="en-US" dirty="0"/>
+              <a:t>"This is the Register Alias Table — the RAT. The RAT is the key to register renaming.</a:t>
+            </a:r>
+          </a:p>
+          <a:p>
+            <a:r>
+              <a:rPr lang="en-US" dirty="0"/>
+              <a:t>Think of it like a mapping table. When an instruction writes to a register, the RAT says 'Okay, x1 is now being written by ROB entry 0011.' When another instruction writes to x1, the RAT updates: 'x1 is now being written by ROB entry 0101.' No conflict.</a:t>
             </a:r>
           </a:p>
           <a:p>
@@ -1749,7 +2008,33 @@
                 <a:ea typeface="+mn-ea"/>
                 <a:cs typeface="+mn-cs"/>
               </a:rPr>
-              <a:t>issueTag_TB</a:t>
+              <a:t>WriteRegister_TB</a:t>
+            </a:r>
+            <a:r>
+              <a:rPr lang="en-US" sz="1200" kern="1200" dirty="0">
+                <a:solidFill>
+                  <a:schemeClr val="tx1"/>
+                </a:solidFill>
+                <a:latin typeface="+mn-lt"/>
+                <a:ea typeface="+mn-ea"/>
+                <a:cs typeface="+mn-cs"/>
+              </a:rPr>
+              <a:t>[4:0]</a:t>
+            </a:r>
+            <a:r>
+              <a:rPr lang="en-US" dirty="0"/>
+              <a:t> — that's the register being written (x0, x1, x2, etc.). Look at </a:t>
+            </a:r>
+            <a:r>
+              <a:rPr lang="en-US" sz="1200" kern="1200" dirty="0" err="1">
+                <a:solidFill>
+                  <a:schemeClr val="tx1"/>
+                </a:solidFill>
+                <a:latin typeface="+mn-lt"/>
+                <a:ea typeface="+mn-ea"/>
+                <a:cs typeface="+mn-cs"/>
+              </a:rPr>
+              <a:t>WriteTag_TB</a:t>
             </a:r>
             <a:r>
               <a:rPr lang="en-US" sz="1200" kern="1200" dirty="0">
@@ -1764,144 +2049,19 @@
             </a:r>
             <a:r>
               <a:rPr lang="en-US" dirty="0"/>
-              <a:t> — that's which instruction is being issued. You see tags 0000, 0001, 0010, 0011 — four different instructions.</a:t>
-            </a:r>
-          </a:p>
-          <a:p>
-            <a:r>
-              <a:rPr lang="en-US" dirty="0"/>
-              <a:t>Now look at </a:t>
-            </a:r>
-            <a:r>
-              <a:rPr lang="en-US" sz="1200" kern="1200" dirty="0">
-                <a:solidFill>
-                  <a:schemeClr val="tx1"/>
-                </a:solidFill>
-                <a:latin typeface="+mn-lt"/>
-                <a:ea typeface="+mn-ea"/>
-                <a:cs typeface="+mn-cs"/>
-              </a:rPr>
-              <a:t>issueSrc1Val_TB</a:t>
-            </a:r>
-            <a:r>
-              <a:rPr lang="en-US" dirty="0"/>
-              <a:t> and </a:t>
-            </a:r>
-            <a:r>
-              <a:rPr lang="en-US" sz="1200" kern="1200" dirty="0">
-                <a:solidFill>
-                  <a:schemeClr val="tx1"/>
-                </a:solidFill>
-                <a:latin typeface="+mn-lt"/>
-                <a:ea typeface="+mn-ea"/>
-                <a:cs typeface="+mn-cs"/>
-              </a:rPr>
-              <a:t>issueSrc2Val_TB</a:t>
-            </a:r>
-            <a:r>
-              <a:rPr lang="en-US" dirty="0"/>
-              <a:t> — these are the operand values. Some show actual values, some show zeros because the operands aren't ready yet.</a:t>
-            </a:r>
-          </a:p>
-          <a:p>
-            <a:r>
-              <a:rPr lang="en-US" dirty="0"/>
-              <a:t>Watch </a:t>
-            </a:r>
-            <a:r>
-              <a:rPr lang="en-US" sz="1200" kern="1200" dirty="0" err="1">
-                <a:solidFill>
-                  <a:schemeClr val="tx1"/>
-                </a:solidFill>
-                <a:latin typeface="+mn-lt"/>
-                <a:ea typeface="+mn-ea"/>
-                <a:cs typeface="+mn-cs"/>
-              </a:rPr>
-              <a:t>cdbValid_TB</a:t>
-            </a:r>
-            <a:r>
-              <a:rPr lang="en-US" dirty="0"/>
-              <a:t> and </a:t>
-            </a:r>
-            <a:r>
-              <a:rPr lang="en-US" sz="1200" kern="1200" dirty="0" err="1">
-                <a:solidFill>
-                  <a:schemeClr val="tx1"/>
-                </a:solidFill>
-                <a:latin typeface="+mn-lt"/>
-                <a:ea typeface="+mn-ea"/>
-                <a:cs typeface="+mn-cs"/>
-              </a:rPr>
-              <a:t>cdbTag_TB</a:t>
-            </a:r>
-            <a:r>
-              <a:rPr lang="en-US" dirty="0"/>
-              <a:t> — the CDB is broadcasting results. When a result appears on the CDB, the RS snoops it. Look at </a:t>
-            </a:r>
-            <a:r>
-              <a:rPr lang="en-US" sz="1200" kern="1200" dirty="0">
-                <a:solidFill>
-                  <a:schemeClr val="tx1"/>
-                </a:solidFill>
-                <a:latin typeface="+mn-lt"/>
-                <a:ea typeface="+mn-ea"/>
-                <a:cs typeface="+mn-cs"/>
-              </a:rPr>
-              <a:t>executeSrc1Val_TB</a:t>
-            </a:r>
-            <a:r>
-              <a:rPr lang="en-US" dirty="0"/>
-              <a:t> and </a:t>
-            </a:r>
-            <a:r>
-              <a:rPr lang="en-US" sz="1200" kern="1200" dirty="0">
-                <a:solidFill>
-                  <a:schemeClr val="tx1"/>
-                </a:solidFill>
-                <a:latin typeface="+mn-lt"/>
-                <a:ea typeface="+mn-ea"/>
-                <a:cs typeface="+mn-cs"/>
-              </a:rPr>
-              <a:t>executeSrc2Val_TB</a:t>
-            </a:r>
-            <a:r>
-              <a:rPr lang="en-US" dirty="0"/>
-              <a:t> — these start as zeros, but when the CDB broadcasts (around 100ns), they get filled in.</a:t>
-            </a:r>
-          </a:p>
-          <a:p>
-            <a:r>
-              <a:rPr lang="en-US" dirty="0"/>
-              <a:t>Finally, </a:t>
-            </a:r>
-            <a:r>
-              <a:rPr lang="en-US" sz="1200" kern="1200" dirty="0" err="1">
-                <a:solidFill>
-                  <a:schemeClr val="tx1"/>
-                </a:solidFill>
-                <a:latin typeface="+mn-lt"/>
-                <a:ea typeface="+mn-ea"/>
-                <a:cs typeface="+mn-cs"/>
-              </a:rPr>
-              <a:t>executeReady_TB</a:t>
-            </a:r>
-            <a:r>
-              <a:rPr lang="en-US" dirty="0"/>
-              <a:t> goes high when both operands are ready. That's when the instruction can execute.</a:t>
-            </a:r>
-          </a:p>
-          <a:p>
-            <a:r>
-              <a:rPr lang="en-US" dirty="0"/>
-              <a:t>The magic here: instruction 1 might execute, then instruction 3 executes before instruction 2, because instruction 3's operands became ready first. </a:t>
-            </a:r>
-            <a:r>
-              <a:rPr lang="en-US" b="1" dirty="0"/>
-              <a:t>That's out-of-order execution.</a:t>
-            </a:r>
-            <a:r>
-              <a:rPr lang="en-US" dirty="0"/>
-              <a:t> The RS doesn't care about program order — it only cares about operand readiness</a:t>
+              <a:t> — that's the ROB entry number.</a:t>
+            </a:r>
+          </a:p>
+          <a:p>
+            <a:r>
+              <a:rPr lang="en-US" dirty="0"/>
+              <a:t>At 20ns, we write x1 with tag 0000. At 40ns, we write x1 again with tag 0001. The RAT tracks both. Now when instruction 1 reads x1, it gets ROB entry 0000. When instruction 2 reads x1, it gets ROB entry 0001. Different ROB entries, no conflict.</a:t>
+            </a:r>
+          </a:p>
+          <a:p>
+            <a:r>
+              <a:rPr lang="en-US" dirty="0"/>
+              <a:t>This is register renaming. It eliminates false data dependencies and lets instructions execute out of order without conflicts."</a:t>
             </a:r>
           </a:p>
           <a:p>
@@ -1926,7 +2086,7 @@
           <a:p>
             <a:fld id="{FA051D29-8EA3-42D3-BB95-BE917086C5B1}" type="slidenum">
               <a:rPr lang="en-US" smtClean="0"/>
-              <a:t>9</a:t>
+              <a:t>8</a:t>
             </a:fld>
             <a:endParaRPr lang="en-US"/>
           </a:p>
@@ -1935,7 +2095,7 @@
     </p:spTree>
     <p:extLst>
       <p:ext uri="{BB962C8B-B14F-4D97-AF65-F5344CB8AC3E}">
-        <p14:creationId xmlns:p14="http://schemas.microsoft.com/office/powerpoint/2010/main" val="815065617"/>
+        <p14:creationId xmlns:p14="http://schemas.microsoft.com/office/powerpoint/2010/main" val="2966007745"/>
       </p:ext>
     </p:extLst>
   </p:cSld>
@@ -1991,24 +2151,16 @@
           <a:p>
             <a:r>
               <a:rPr lang="en-US" dirty="0"/>
-              <a:t>Even </a:t>
-            </a:r>
-            <a:r>
-              <a:rPr lang="en-US" dirty="0" err="1"/>
-              <a:t>thugh</a:t>
-            </a:r>
-            <a:r>
-              <a:rPr lang="en-US" dirty="0"/>
-              <a:t> instructions might execute out of order, the ROB commits them in the original program order. This is the safety mechanism. The processor looks like it executed sequentially to the outside world.</a:t>
-            </a:r>
-          </a:p>
-          <a:p>
-            <a:endParaRPr lang="en-US" dirty="0"/>
-          </a:p>
-          <a:p>
-            <a:r>
-              <a:rPr lang="en-US" dirty="0"/>
-              <a:t>This is the Reorder Buffer — the ROB. The ROB is the safety mechanism that makes out-of-order execution safe.</a:t>
+              <a:t>Here’s when out-of-order execution actually happens. The second instruction has to wait for an operand, but the third instruction doesn’t. The third can execute first. RS watches the CDB, and as soon as its operand appears its ready to go.</a:t>
+            </a:r>
+          </a:p>
+          <a:p>
+            <a:endParaRPr lang="en-US" dirty="0"/>
+          </a:p>
+          <a:p>
+            <a:r>
+              <a:rPr lang="en-US" dirty="0"/>
+              <a:t>The Reservation Station is where instructions wait for their operands and where out-of-order execution happens.</a:t>
             </a:r>
           </a:p>
           <a:p>
@@ -2025,7 +2177,7 @@
                 <a:ea typeface="+mn-ea"/>
                 <a:cs typeface="+mn-cs"/>
               </a:rPr>
-              <a:t>enqueueDestinationReg_TB</a:t>
+              <a:t>issueTag_TB</a:t>
             </a:r>
             <a:r>
               <a:rPr lang="en-US" sz="1200" kern="1200" dirty="0">
@@ -2036,17 +2188,53 @@
                 <a:ea typeface="+mn-ea"/>
                 <a:cs typeface="+mn-cs"/>
               </a:rPr>
-              <a:t>[4:0]</a:t>
-            </a:r>
-            <a:r>
-              <a:rPr lang="en-US" dirty="0"/>
-              <a:t> — different instructions writing to different registers (x1, x2, x3, x4, etc.). They enqueue into the ROB one by one.</a:t>
+              <a:t>[3:0]</a:t>
+            </a:r>
+            <a:r>
+              <a:rPr lang="en-US" dirty="0"/>
+              <a:t> — that's which instruction is being issued. You see tags 0000, 0001, 0010, 0011 — four different instructions.</a:t>
             </a:r>
           </a:p>
           <a:p>
             <a:r>
               <a:rPr lang="en-US" dirty="0"/>
               <a:t>Now look at </a:t>
+            </a:r>
+            <a:r>
+              <a:rPr lang="en-US" sz="1200" kern="1200" dirty="0">
+                <a:solidFill>
+                  <a:schemeClr val="tx1"/>
+                </a:solidFill>
+                <a:latin typeface="+mn-lt"/>
+                <a:ea typeface="+mn-ea"/>
+                <a:cs typeface="+mn-cs"/>
+              </a:rPr>
+              <a:t>issueSrc1Val_TB</a:t>
+            </a:r>
+            <a:r>
+              <a:rPr lang="en-US" dirty="0"/>
+              <a:t> and </a:t>
+            </a:r>
+            <a:r>
+              <a:rPr lang="en-US" sz="1200" kern="1200" dirty="0">
+                <a:solidFill>
+                  <a:schemeClr val="tx1"/>
+                </a:solidFill>
+                <a:latin typeface="+mn-lt"/>
+                <a:ea typeface="+mn-ea"/>
+                <a:cs typeface="+mn-cs"/>
+              </a:rPr>
+              <a:t>issueSrc2Val_TB</a:t>
+            </a:r>
+            <a:r>
+              <a:rPr lang="en-US" dirty="0"/>
+              <a:t> — these are the operand values. Some show actual values, some show zeros because the operands aren't ready yet.</a:t>
+            </a:r>
+          </a:p>
+          <a:p>
+            <a:r>
+              <a:rPr lang="en-US" dirty="0"/>
+              <a:t>Watch </a:t>
             </a:r>
             <a:r>
               <a:rPr lang="en-US" sz="1200" kern="1200" dirty="0" err="1">
@@ -2076,13 +2264,43 @@
             </a:r>
             <a:r>
               <a:rPr lang="en-US" dirty="0"/>
-              <a:t> — when the CDB broadcasts a result, it includes a tag that says 'This result is for ROB entry 0001.' The ROB marks that entry done.</a:t>
-            </a:r>
-          </a:p>
-          <a:p>
-            <a:r>
-              <a:rPr lang="en-US" dirty="0"/>
-              <a:t>Here's the key: look at </a:t>
+              <a:t> — the CDB is broadcasting results. When a result appears on the CDB, the RS snoops it. Look at </a:t>
+            </a:r>
+            <a:r>
+              <a:rPr lang="en-US" sz="1200" kern="1200" dirty="0">
+                <a:solidFill>
+                  <a:schemeClr val="tx1"/>
+                </a:solidFill>
+                <a:latin typeface="+mn-lt"/>
+                <a:ea typeface="+mn-ea"/>
+                <a:cs typeface="+mn-cs"/>
+              </a:rPr>
+              <a:t>executeSrc1Val_TB</a:t>
+            </a:r>
+            <a:r>
+              <a:rPr lang="en-US" dirty="0"/>
+              <a:t> and </a:t>
+            </a:r>
+            <a:r>
+              <a:rPr lang="en-US" sz="1200" kern="1200" dirty="0">
+                <a:solidFill>
+                  <a:schemeClr val="tx1"/>
+                </a:solidFill>
+                <a:latin typeface="+mn-lt"/>
+                <a:ea typeface="+mn-ea"/>
+                <a:cs typeface="+mn-cs"/>
+              </a:rPr>
+              <a:t>executeSrc2Val_TB</a:t>
+            </a:r>
+            <a:r>
+              <a:rPr lang="en-US" dirty="0"/>
+              <a:t> — these start as zeros, but when the CDB broadcasts (around 100ns), they get filled in.</a:t>
+            </a:r>
+          </a:p>
+          <a:p>
+            <a:r>
+              <a:rPr lang="en-US" dirty="0"/>
+              <a:t>Finally, </a:t>
             </a:r>
             <a:r>
               <a:rPr lang="en-US" sz="1200" kern="1200" dirty="0" err="1">
@@ -2093,84 +2311,25 @@
                 <a:ea typeface="+mn-ea"/>
                 <a:cs typeface="+mn-cs"/>
               </a:rPr>
-              <a:t>commitDestinationReg_TB</a:t>
-            </a:r>
-            <a:r>
-              <a:rPr lang="en-US" sz="1200" kern="1200" dirty="0">
-                <a:solidFill>
-                  <a:schemeClr val="tx1"/>
-                </a:solidFill>
-                <a:latin typeface="+mn-lt"/>
-                <a:ea typeface="+mn-ea"/>
-                <a:cs typeface="+mn-cs"/>
-              </a:rPr>
-              <a:t>[4:0]</a:t>
-            </a:r>
-            <a:r>
-              <a:rPr lang="en-US" dirty="0"/>
-              <a:t> and </a:t>
-            </a:r>
-            <a:r>
-              <a:rPr lang="en-US" sz="1200" kern="1200" dirty="0" err="1">
-                <a:solidFill>
-                  <a:schemeClr val="tx1"/>
-                </a:solidFill>
-                <a:latin typeface="+mn-lt"/>
-                <a:ea typeface="+mn-ea"/>
-                <a:cs typeface="+mn-cs"/>
-              </a:rPr>
-              <a:t>commitResult_TB</a:t>
-            </a:r>
-            <a:r>
-              <a:rPr lang="en-US" sz="1200" kern="1200" dirty="0">
-                <a:solidFill>
-                  <a:schemeClr val="tx1"/>
-                </a:solidFill>
-                <a:latin typeface="+mn-lt"/>
-                <a:ea typeface="+mn-ea"/>
-                <a:cs typeface="+mn-cs"/>
-              </a:rPr>
-              <a:t>[31:0]</a:t>
-            </a:r>
-            <a:r>
-              <a:rPr lang="en-US" dirty="0"/>
-              <a:t>. </a:t>
-            </a:r>
-            <a:r>
-              <a:rPr lang="en-US" sz="1200" kern="1200" dirty="0" err="1">
-                <a:solidFill>
-                  <a:schemeClr val="tx1"/>
-                </a:solidFill>
-                <a:latin typeface="+mn-lt"/>
-                <a:ea typeface="+mn-ea"/>
-                <a:cs typeface="+mn-cs"/>
-              </a:rPr>
-              <a:t>commitEnable_TB</a:t>
-            </a:r>
-            <a:r>
-              <a:rPr lang="en-US" dirty="0"/>
-              <a:t> goes high in sequence: at one time, instruction to x1 commits. Then instruction to x2. Then instruction to x3. </a:t>
+              <a:t>executeReady_TB</a:t>
+            </a:r>
+            <a:r>
+              <a:rPr lang="en-US" dirty="0"/>
+              <a:t> goes high when both operands are ready. That's when the instruction can execute.</a:t>
+            </a:r>
+          </a:p>
+          <a:p>
+            <a:r>
+              <a:rPr lang="en-US" dirty="0"/>
+              <a:t>The magic here: instruction 1 might execute, then instruction 3 executes before instruction 2, because instruction 3's operands became ready first. </a:t>
             </a:r>
             <a:r>
               <a:rPr lang="en-US" b="1" dirty="0"/>
-              <a:t>In program order.</a:t>
-            </a:r>
-            <a:endParaRPr lang="en-US" dirty="0"/>
-          </a:p>
-          <a:p>
-            <a:r>
-              <a:rPr lang="en-US" dirty="0"/>
-              <a:t>Even though the instructions might have executed out of order (CDB broadcasts happening at different times), the ROB makes sure they commit in order. Instruction 1 commits first, then instruction 2, then instruction 3.</a:t>
-            </a:r>
-          </a:p>
-          <a:p>
-            <a:r>
-              <a:rPr lang="en-US" dirty="0"/>
-              <a:t>This is why it's safe to go out-of-order. The ROB ensures the processor behaves as if instructions executed sequentially. </a:t>
-            </a:r>
-            <a:r>
-              <a:rPr lang="en-US"/>
-              <a:t>To the outside world, everything looks correct.</a:t>
+              <a:t>That's out-of-order execution.</a:t>
+            </a:r>
+            <a:r>
+              <a:rPr lang="en-US" dirty="0"/>
+              <a:t> The RS doesn't care about program order — it only cares about operand readiness</a:t>
             </a:r>
           </a:p>
           <a:p>
@@ -2195,7 +2354,7 @@
           <a:p>
             <a:fld id="{FA051D29-8EA3-42D3-BB95-BE917086C5B1}" type="slidenum">
               <a:rPr lang="en-US" smtClean="0"/>
-              <a:t>10</a:t>
+              <a:t>9</a:t>
             </a:fld>
             <a:endParaRPr lang="en-US"/>
           </a:p>
@@ -2204,7 +2363,7 @@
     </p:spTree>
     <p:extLst>
       <p:ext uri="{BB962C8B-B14F-4D97-AF65-F5344CB8AC3E}">
-        <p14:creationId xmlns:p14="http://schemas.microsoft.com/office/powerpoint/2010/main" val="748576835"/>
+        <p14:creationId xmlns:p14="http://schemas.microsoft.com/office/powerpoint/2010/main" val="815065617"/>
       </p:ext>
     </p:extLst>
   </p:cSld>
@@ -2260,13 +2419,30 @@
           <a:p>
             <a:r>
               <a:rPr lang="en-US" dirty="0"/>
-              <a:t>This is the complete pipeline executing three instructions: ADDI, LW, and ADD. Let me walk you through what's happening.</a:t>
-            </a:r>
-          </a:p>
-          <a:p>
-            <a:r>
-              <a:rPr lang="en-US" dirty="0"/>
-              <a:t>First, look at </a:t>
+              <a:t>Even </a:t>
+            </a:r>
+            <a:r>
+              <a:rPr lang="en-US" dirty="0" err="1"/>
+              <a:t>thugh</a:t>
+            </a:r>
+            <a:r>
+              <a:rPr lang="en-US" dirty="0"/>
+              <a:t> instructions might execute out of order, the ROB commits them in the original program order. This is the safety mechanism. The processor looks like it executed sequentially to the outside world.</a:t>
+            </a:r>
+          </a:p>
+          <a:p>
+            <a:endParaRPr lang="en-US" dirty="0"/>
+          </a:p>
+          <a:p>
+            <a:r>
+              <a:rPr lang="en-US" dirty="0"/>
+              <a:t>This is the Reorder Buffer — the ROB. The ROB is the safety mechanism that makes out-of-order execution safe.</a:t>
+            </a:r>
+          </a:p>
+          <a:p>
+            <a:r>
+              <a:rPr lang="en-US" dirty="0"/>
+              <a:t>Look at </a:t>
             </a:r>
             <a:r>
               <a:rPr lang="en-US" sz="1200" kern="1200" dirty="0" err="1">
@@ -2277,17 +2453,28 @@
                 <a:ea typeface="+mn-ea"/>
                 <a:cs typeface="+mn-cs"/>
               </a:rPr>
-              <a:t>instructionInput_TB</a:t>
-            </a:r>
-            <a:r>
-              <a:rPr lang="en-US" dirty="0"/>
-              <a:t> — you see three different instruction values being fed in at different times. That's ADDI, then LW, then ADD.</a:t>
-            </a:r>
-          </a:p>
-          <a:p>
-            <a:r>
-              <a:rPr lang="en-US" dirty="0"/>
-              <a:t>Now watch the key signals: </a:t>
+              <a:t>enqueueDestinationReg_TB</a:t>
+            </a:r>
+            <a:r>
+              <a:rPr lang="en-US" sz="1200" kern="1200" dirty="0">
+                <a:solidFill>
+                  <a:schemeClr val="tx1"/>
+                </a:solidFill>
+                <a:latin typeface="+mn-lt"/>
+                <a:ea typeface="+mn-ea"/>
+                <a:cs typeface="+mn-cs"/>
+              </a:rPr>
+              <a:t>[4:0]</a:t>
+            </a:r>
+            <a:r>
+              <a:rPr lang="en-US" dirty="0"/>
+              <a:t> — different instructions writing to different registers (x1, x2, x3, x4, etc.). They enqueue into the ROB one by one.</a:t>
+            </a:r>
+          </a:p>
+          <a:p>
+            <a:r>
+              <a:rPr lang="en-US" dirty="0"/>
+              <a:t>Now look at </a:t>
             </a:r>
             <a:r>
               <a:rPr lang="en-US" sz="1200" kern="1200" dirty="0" err="1">
@@ -2298,7 +2485,7 @@
                 <a:ea typeface="+mn-ea"/>
                 <a:cs typeface="+mn-cs"/>
               </a:rPr>
-              <a:t>cdbValid</a:t>
+              <a:t>cdbValid_TB</a:t>
             </a:r>
             <a:r>
               <a:rPr lang="en-US" dirty="0"/>
@@ -2313,11 +2500,17 @@
                 <a:ea typeface="+mn-ea"/>
                 <a:cs typeface="+mn-cs"/>
               </a:rPr>
-              <a:t>cdbTag</a:t>
-            </a:r>
-            <a:r>
-              <a:rPr lang="en-US" dirty="0"/>
-              <a:t>. Notice that </a:t>
+              <a:t>cdbTag_TB</a:t>
+            </a:r>
+            <a:r>
+              <a:rPr lang="en-US" dirty="0"/>
+              <a:t> — when the CDB broadcasts a result, it includes a tag that says 'This result is for ROB entry 0001.' The ROB marks that entry done.</a:t>
+            </a:r>
+          </a:p>
+          <a:p>
+            <a:r>
+              <a:rPr lang="en-US" dirty="0"/>
+              <a:t>Here's the key: look at </a:t>
             </a:r>
             <a:r>
               <a:rPr lang="en-US" sz="1200" kern="1200" dirty="0" err="1">
@@ -2328,30 +2521,22 @@
                 <a:ea typeface="+mn-ea"/>
                 <a:cs typeface="+mn-cs"/>
               </a:rPr>
-              <a:t>cdbValid</a:t>
-            </a:r>
-            <a:r>
-              <a:rPr lang="en-US" dirty="0"/>
-              <a:t> pulses (goes high) at </a:t>
-            </a:r>
-            <a:r>
-              <a:rPr lang="en-US" b="1" dirty="0"/>
-              <a:t>different times</a:t>
-            </a:r>
-            <a:r>
-              <a:rPr lang="en-US" dirty="0"/>
-              <a:t> — around 80ns, then 120ns, then 180ns. That means different instructions are finishing execution at different times. </a:t>
-            </a:r>
-            <a:r>
-              <a:rPr lang="en-US" b="1" dirty="0"/>
-              <a:t>That's out-of-order execution.</a:t>
-            </a:r>
-            <a:endParaRPr lang="en-US" dirty="0"/>
-          </a:p>
-          <a:p>
-            <a:r>
-              <a:rPr lang="en-US" dirty="0"/>
-              <a:t>But here's the magic: look at </a:t>
+              <a:t>commitDestinationReg_TB</a:t>
+            </a:r>
+            <a:r>
+              <a:rPr lang="en-US" sz="1200" kern="1200" dirty="0">
+                <a:solidFill>
+                  <a:schemeClr val="tx1"/>
+                </a:solidFill>
+                <a:latin typeface="+mn-lt"/>
+                <a:ea typeface="+mn-ea"/>
+                <a:cs typeface="+mn-cs"/>
+              </a:rPr>
+              <a:t>[4:0]</a:t>
+            </a:r>
+            <a:r>
+              <a:rPr lang="en-US" dirty="0"/>
+              <a:t> and </a:t>
             </a:r>
             <a:r>
               <a:rPr lang="en-US" sz="1200" kern="1200" dirty="0" err="1">
@@ -2362,19 +2547,22 @@
                 <a:ea typeface="+mn-ea"/>
                 <a:cs typeface="+mn-cs"/>
               </a:rPr>
-              <a:t>commitEnable</a:t>
-            </a:r>
-            <a:r>
-              <a:rPr lang="en-US" dirty="0"/>
-              <a:t> — it pulses </a:t>
-            </a:r>
-            <a:r>
-              <a:rPr lang="en-US" b="1" dirty="0"/>
-              <a:t>sequentially</a:t>
-            </a:r>
-            <a:r>
-              <a:rPr lang="en-US" dirty="0"/>
-              <a:t>. One pulse, then the next, then the next. And </a:t>
+              <a:t>commitResult_TB</a:t>
+            </a:r>
+            <a:r>
+              <a:rPr lang="en-US" sz="1200" kern="1200" dirty="0">
+                <a:solidFill>
+                  <a:schemeClr val="tx1"/>
+                </a:solidFill>
+                <a:latin typeface="+mn-lt"/>
+                <a:ea typeface="+mn-ea"/>
+                <a:cs typeface="+mn-cs"/>
+              </a:rPr>
+              <a:t>[31:0]</a:t>
+            </a:r>
+            <a:r>
+              <a:rPr lang="en-US" dirty="0"/>
+              <a:t>. </a:t>
             </a:r>
             <a:r>
               <a:rPr lang="en-US" sz="1200" kern="1200" dirty="0" err="1">
@@ -2385,17 +2573,32 @@
                 <a:ea typeface="+mn-ea"/>
                 <a:cs typeface="+mn-cs"/>
               </a:rPr>
-              <a:t>cdbTag</a:t>
-            </a:r>
-            <a:r>
-              <a:rPr lang="en-US" dirty="0"/>
-              <a:t> shows the sequence: 0000, then 0100, then 0000. The instructions commit in program order, even though they executed out of order.</a:t>
-            </a:r>
-          </a:p>
-          <a:p>
-            <a:r>
-              <a:rPr lang="en-US" dirty="0"/>
-              <a:t>This is Tomasulo's Algorithm working. Instructions execute whenever their operands are ready, not in program order. But they commit to the register file in program order, maintaining correctness. That's why it's safe, and that's why it's fast."</a:t>
+              <a:t>commitEnable_TB</a:t>
+            </a:r>
+            <a:r>
+              <a:rPr lang="en-US" dirty="0"/>
+              <a:t> goes high in sequence: at one time, instruction to x1 commits. Then instruction to x2. Then instruction to x3. </a:t>
+            </a:r>
+            <a:r>
+              <a:rPr lang="en-US" b="1" dirty="0"/>
+              <a:t>In program order.</a:t>
+            </a:r>
+            <a:endParaRPr lang="en-US" dirty="0"/>
+          </a:p>
+          <a:p>
+            <a:r>
+              <a:rPr lang="en-US" dirty="0"/>
+              <a:t>Even though the instructions might have executed out of order (CDB broadcasts happening at different times), the ROB makes sure they commit in order. Instruction 1 commits first, then instruction 2, then instruction 3.</a:t>
+            </a:r>
+          </a:p>
+          <a:p>
+            <a:r>
+              <a:rPr lang="en-US" dirty="0"/>
+              <a:t>This is why it's safe to go out-of-order. The ROB ensures the processor behaves as if instructions executed sequentially. </a:t>
+            </a:r>
+            <a:r>
+              <a:rPr lang="en-US"/>
+              <a:t>To the outside world, everything looks correct.</a:t>
             </a:r>
           </a:p>
           <a:p>
@@ -2420,7 +2623,7 @@
           <a:p>
             <a:fld id="{FA051D29-8EA3-42D3-BB95-BE917086C5B1}" type="slidenum">
               <a:rPr lang="en-US" smtClean="0"/>
-              <a:t>11</a:t>
+              <a:t>10</a:t>
             </a:fld>
             <a:endParaRPr lang="en-US"/>
           </a:p>
@@ -2429,7 +2632,7 @@
     </p:spTree>
     <p:extLst>
       <p:ext uri="{BB962C8B-B14F-4D97-AF65-F5344CB8AC3E}">
-        <p14:creationId xmlns:p14="http://schemas.microsoft.com/office/powerpoint/2010/main" val="3295559901"/>
+        <p14:creationId xmlns:p14="http://schemas.microsoft.com/office/powerpoint/2010/main" val="748576835"/>
       </p:ext>
     </p:extLst>
   </p:cSld>
@@ -2677,7 +2880,7 @@
           <a:p>
             <a:fld id="{3CA67B82-C4A5-4D0B-88B1-A5AE5A8149E2}" type="datetime1">
               <a:rPr lang="en-US" smtClean="0"/>
-              <a:t>5/3/2026</a:t>
+              <a:t>5/6/2026</a:t>
             </a:fld>
             <a:endParaRPr lang="en-US" dirty="0"/>
           </a:p>
@@ -2880,7 +3083,7 @@
           <a:p>
             <a:fld id="{3269A706-2ED0-4A80-BB08-949A53B00FD1}" type="datetime1">
               <a:rPr lang="en-US" smtClean="0"/>
-              <a:t>5/3/2026</a:t>
+              <a:t>5/6/2026</a:t>
             </a:fld>
             <a:endParaRPr lang="en-US" dirty="0"/>
           </a:p>
@@ -3242,7 +3445,7 @@
           <a:p>
             <a:fld id="{479DDB92-2E6C-4FBF-9F28-B3258F4C0E9E}" type="datetime1">
               <a:rPr lang="en-US" smtClean="0"/>
-              <a:t>5/3/2026</a:t>
+              <a:t>5/6/2026</a:t>
             </a:fld>
             <a:endParaRPr lang="en-US" dirty="0"/>
           </a:p>
@@ -3440,7 +3643,7 @@
           <a:p>
             <a:fld id="{D860822F-C685-4CBB-BA0A-59681D748C9B}" type="datetime1">
               <a:rPr lang="en-US" smtClean="0"/>
-              <a:t>5/3/2026</a:t>
+              <a:t>5/6/2026</a:t>
             </a:fld>
             <a:endParaRPr lang="en-US" dirty="0"/>
           </a:p>
@@ -3752,7 +3955,7 @@
           <a:p>
             <a:fld id="{4C099200-CAA2-42FE-8E0C-629199D79E82}" type="datetime1">
               <a:rPr lang="en-US" smtClean="0"/>
-              <a:t>5/3/2026</a:t>
+              <a:t>5/6/2026</a:t>
             </a:fld>
             <a:endParaRPr lang="en-US" dirty="0"/>
           </a:p>
@@ -4005,7 +4208,7 @@
           <a:p>
             <a:fld id="{93978383-6361-4681-94CB-B05E3F778AB1}" type="datetime1">
               <a:rPr lang="en-US" smtClean="0"/>
-              <a:t>5/3/2026</a:t>
+              <a:t>5/6/2026</a:t>
             </a:fld>
             <a:endParaRPr lang="en-US" dirty="0"/>
           </a:p>
@@ -4427,7 +4630,7 @@
           <a:p>
             <a:fld id="{2DE1880E-89C0-4264-907F-B84184ED5451}" type="datetime1">
               <a:rPr lang="en-US" smtClean="0"/>
-              <a:t>5/3/2026</a:t>
+              <a:t>5/6/2026</a:t>
             </a:fld>
             <a:endParaRPr lang="en-US" dirty="0"/>
           </a:p>
@@ -4550,7 +4753,7 @@
           <a:p>
             <a:fld id="{4246E03B-5F90-479F-A0F3-8FD67B69A49E}" type="datetime1">
               <a:rPr lang="en-US" smtClean="0"/>
-              <a:t>5/3/2026</a:t>
+              <a:t>5/6/2026</a:t>
             </a:fld>
             <a:endParaRPr lang="en-US" dirty="0"/>
           </a:p>
@@ -4645,7 +4848,7 @@
           <a:p>
             <a:fld id="{DAAC49BA-6CDE-425C-BCD1-FCA14747487A}" type="datetime1">
               <a:rPr lang="en-US" smtClean="0"/>
-              <a:t>5/3/2026</a:t>
+              <a:t>5/6/2026</a:t>
             </a:fld>
             <a:endParaRPr lang="en-US" dirty="0"/>
           </a:p>
@@ -5022,7 +5225,7 @@
           <a:p>
             <a:fld id="{ECCF5CE3-DEB2-4211-92A1-FF6473EE2E64}" type="datetime1">
               <a:rPr lang="en-US" smtClean="0"/>
-              <a:t>5/3/2026</a:t>
+              <a:t>5/6/2026</a:t>
             </a:fld>
             <a:endParaRPr lang="en-US" dirty="0"/>
           </a:p>
@@ -5315,7 +5518,7 @@
           <a:p>
             <a:fld id="{9D80BB91-7165-49BB-AAE1-BA6B622F620F}" type="datetime1">
               <a:rPr lang="en-US" smtClean="0"/>
-              <a:t>5/3/2026</a:t>
+              <a:t>5/6/2026</a:t>
             </a:fld>
             <a:endParaRPr lang="en-US" dirty="0"/>
           </a:p>
@@ -5530,7 +5733,7 @@
           <a:p>
             <a:fld id="{01ED0F8D-6559-484E-AA4A-61BC93126D2D}" type="datetime1">
               <a:rPr lang="en-US" smtClean="0"/>
-              <a:t>5/3/2026</a:t>
+              <a:t>5/6/2026</a:t>
             </a:fld>
             <a:endParaRPr lang="en-US" dirty="0"/>
           </a:p>

</xml_diff>